<commit_message>
Docs: refresh investor pitch with the fund-side intelligence story
Funds & SPVs pillar now covers portfolio intelligence (KPI collection,
signals, benchmarking, tear sheets), deal-flow + LP-fundraise CRM with
relationship intelligence, and valuation tracking; LP pillar gains
quarterly reports, call notices and founder KPI self-reporting; new
'Fund-ops tools (global)' positioning row (Vestberry / 4Degrees / Carta
fund admin); ask updated. PPTX regenerated to match.

Co-Authored-By: Claude Opus 4.8 <noreply@anthropic.com>
</commit_message>
<xml_diff>
--- a/docs/Paper_Investor_Pitch.pptx
+++ b/docs/Paper_Investor_Pitch.pptx
@@ -6385,7 +6385,7 @@
                 </a:solidFill>
                 <a:latin typeface="Segoe UI"/>
               </a:rPr>
-              <a:t>Board &amp; ROC compliance, registers — plus full SEBI AIF &amp; SPV administration.</a:t>
+              <a:t>Board &amp; ROC compliance, registers — plus SEBI AIF &amp; SPV administration with portfolio intelligence built in.</a:t>
             </a:r>
           </a:p>
         </p:txBody>
@@ -6787,7 +6787,7 @@
                 </a:solidFill>
                 <a:latin typeface="Segoe UI"/>
               </a:rPr>
-              <a:t>•  LP capital accounts, drawdowns &amp; unitised NAV</a:t>
+              <a:t>•  Capital accounts, waterfall, NAV &amp; 64C/64D</a:t>
             </a:r>
           </a:p>
           <a:p>
@@ -6809,7 +6809,7 @@
                 </a:solidFill>
                 <a:latin typeface="Segoe UI"/>
               </a:rPr>
-              <a:t>•  Waterfall (hurdle + catch-up); XIRR / DPI / TVPI</a:t>
+              <a:t>•  KPI collection, risk signals &amp; tear sheets</a:t>
             </a:r>
           </a:p>
           <a:p>
@@ -6831,7 +6831,7 @@
                 </a:solidFill>
                 <a:latin typeface="Segoe UI"/>
               </a:rPr>
-              <a:t>•  Form 64C/64D &amp; SEBI AIF compliance calendar</a:t>
+              <a:t>•  Deal-flow &amp; LP CRM w/ relationship intelligence</a:t>
             </a:r>
           </a:p>
         </p:txBody>
@@ -7032,7 +7032,7 @@
                 </a:solidFill>
                 <a:latin typeface="Segoe UI"/>
               </a:rPr>
-              <a:t>•  Portfolio value, vesting &amp; capital statements</a:t>
+              <a:t>•  Statements, quarterly LP reports &amp; call notices</a:t>
             </a:r>
           </a:p>
           <a:p>
@@ -7054,7 +7054,7 @@
                 </a:solidFill>
                 <a:latin typeface="Segoe UI"/>
               </a:rPr>
-              <a:t>•  Commit to deals; record resolution consents</a:t>
+              <a:t>•  Founders report KPIs from the same portal</a:t>
             </a:r>
           </a:p>
         </p:txBody>
@@ -12837,7 +12837,7 @@
         </p:nvSpPr>
         <p:spPr>
           <a:xfrm>
-            <a:off x="731520" y="2368296"/>
+            <a:off x="731520" y="2258568"/>
             <a:ext cx="2743200" cy="548640"/>
           </a:xfrm>
           <a:prstGeom prst="rect">
@@ -12860,7 +12860,7 @@
               </a:spcAft>
             </a:pPr>
             <a:r>
-              <a:rPr sz="1600" b="1" i="0">
+              <a:rPr sz="1500" b="1" i="0">
                 <a:solidFill>
                   <a:srgbClr val="17352A"/>
                 </a:solidFill>
@@ -12879,8 +12879,8 @@
         </p:nvSpPr>
         <p:spPr>
           <a:xfrm>
-            <a:off x="3703320" y="2295144"/>
-            <a:ext cx="7802575" cy="731520"/>
+            <a:off x="3703320" y="2176272"/>
+            <a:ext cx="7802575" cy="685800"/>
           </a:xfrm>
           <a:prstGeom prst="rect">
             <a:avLst/>
@@ -12895,7 +12895,7 @@
           <a:p>
             <a:pPr algn="l">
               <a:lnSpc>
-                <a:spcPct val="115000"/>
+                <a:spcPct val="112000"/>
               </a:lnSpc>
               <a:spcBef>
                 <a:spcPts val="0"/>
@@ -12905,7 +12905,7 @@
               </a:spcAft>
             </a:pPr>
             <a:r>
-              <a:rPr sz="1300" b="0" i="0">
+              <a:rPr sz="1200" b="0" i="0">
                 <a:solidFill>
                   <a:srgbClr val="5C6B62"/>
                 </a:solidFill>
@@ -12924,7 +12924,7 @@
         </p:nvSpPr>
         <p:spPr>
           <a:xfrm>
-            <a:off x="731520" y="3026664"/>
+            <a:off x="731520" y="2862072"/>
             <a:ext cx="10728655" cy="10972"/>
           </a:xfrm>
           <a:prstGeom prst="rect">
@@ -12968,7 +12968,7 @@
         </p:nvSpPr>
         <p:spPr>
           <a:xfrm>
-            <a:off x="731520" y="3282696"/>
+            <a:off x="731520" y="3081528"/>
             <a:ext cx="2743200" cy="548640"/>
           </a:xfrm>
           <a:prstGeom prst="rect">
@@ -12991,13 +12991,13 @@
               </a:spcAft>
             </a:pPr>
             <a:r>
-              <a:rPr sz="1600" b="1" i="0">
+              <a:rPr sz="1500" b="1" i="0">
                 <a:solidFill>
                   <a:srgbClr val="17352A"/>
                 </a:solidFill>
                 <a:latin typeface="Georgia"/>
               </a:rPr>
-              <a:t>Point tools (India)</a:t>
+              <a:t>Fund-ops tools (global)</a:t>
             </a:r>
           </a:p>
         </p:txBody>
@@ -13010,8 +13010,8 @@
         </p:nvSpPr>
         <p:spPr>
           <a:xfrm>
-            <a:off x="3703320" y="3209544"/>
-            <a:ext cx="7802575" cy="731520"/>
+            <a:off x="3703320" y="2999232"/>
+            <a:ext cx="7802575" cy="685800"/>
           </a:xfrm>
           <a:prstGeom prst="rect">
             <a:avLst/>
@@ -13026,7 +13026,7 @@
           <a:p>
             <a:pPr algn="l">
               <a:lnSpc>
-                <a:spcPct val="115000"/>
+                <a:spcPct val="112000"/>
               </a:lnSpc>
               <a:spcBef>
                 <a:spcPts val="0"/>
@@ -13036,13 +13036,13 @@
               </a:spcAft>
             </a:pPr>
             <a:r>
-              <a:rPr sz="1300" b="0" i="0">
+              <a:rPr sz="1200" b="0" i="0">
                 <a:solidFill>
                   <a:srgbClr val="5C6B62"/>
                 </a:solidFill>
                 <a:latin typeface="Segoe UI"/>
               </a:rPr>
-              <a:t>Solve one slice — a cap table, or e-sign, or a tracker. The founder still stitches five vendors together.</a:t>
+              <a:t>Vestberry, 4Degrees, Carta fund admin — portfolio intelligence, deal CRM and fund accounting as three more dollar subscriptions, none SEBI-native.</a:t>
             </a:r>
           </a:p>
         </p:txBody>
@@ -13055,7 +13055,7 @@
         </p:nvSpPr>
         <p:spPr>
           <a:xfrm>
-            <a:off x="731520" y="3941064"/>
+            <a:off x="731520" y="3685032"/>
             <a:ext cx="10728655" cy="10972"/>
           </a:xfrm>
           <a:prstGeom prst="rect">
@@ -13099,7 +13099,7 @@
         </p:nvSpPr>
         <p:spPr>
           <a:xfrm>
-            <a:off x="731520" y="4197096"/>
+            <a:off x="731520" y="3904488"/>
             <a:ext cx="2743200" cy="548640"/>
           </a:xfrm>
           <a:prstGeom prst="rect">
@@ -13122,13 +13122,13 @@
               </a:spcAft>
             </a:pPr>
             <a:r>
-              <a:rPr sz="1600" b="1" i="0">
+              <a:rPr sz="1500" b="1" i="0">
                 <a:solidFill>
                   <a:srgbClr val="17352A"/>
                 </a:solidFill>
                 <a:latin typeface="Georgia"/>
               </a:rPr>
-              <a:t>CS / CA retainers</a:t>
+              <a:t>Point tools (India)</a:t>
             </a:r>
           </a:p>
         </p:txBody>
@@ -13141,8 +13141,8 @@
         </p:nvSpPr>
         <p:spPr>
           <a:xfrm>
-            <a:off x="3703320" y="4123944"/>
-            <a:ext cx="7802575" cy="731520"/>
+            <a:off x="3703320" y="3822192"/>
+            <a:ext cx="7802575" cy="685800"/>
           </a:xfrm>
           <a:prstGeom prst="rect">
             <a:avLst/>
@@ -13157,7 +13157,7 @@
           <a:p>
             <a:pPr algn="l">
               <a:lnSpc>
-                <a:spcPct val="115000"/>
+                <a:spcPct val="112000"/>
               </a:lnSpc>
               <a:spcBef>
                 <a:spcPts val="0"/>
@@ -13167,13 +13167,13 @@
               </a:spcAft>
             </a:pPr>
             <a:r>
-              <a:rPr sz="1300" b="0" i="0">
+              <a:rPr sz="1200" b="0" i="0">
                 <a:solidFill>
                   <a:srgbClr val="5C6B62"/>
                 </a:solidFill>
                 <a:latin typeface="Segoe UI"/>
               </a:rPr>
-              <a:t>The default today: reliable but manual, opaque and expensive, with company data trapped in someone's inbox.</a:t>
+              <a:t>Solve one slice — a cap table, or e-sign, or a tracker. The founder still stitches five vendors together.</a:t>
             </a:r>
           </a:p>
         </p:txBody>
@@ -13186,7 +13186,7 @@
         </p:nvSpPr>
         <p:spPr>
           <a:xfrm>
-            <a:off x="731520" y="4855464"/>
+            <a:off x="731520" y="4507992"/>
             <a:ext cx="10728655" cy="10972"/>
           </a:xfrm>
           <a:prstGeom prst="rect">
@@ -13224,14 +13224,145 @@
       </p:sp>
       <p:sp>
         <p:nvSpPr>
-          <p:cNvPr id="15" name="Rounded Rectangle 14"/>
+          <p:cNvPr id="15" name="TextBox 14"/>
+          <p:cNvSpPr txBox="1"/>
+          <p:nvPr/>
+        </p:nvSpPr>
+        <p:spPr>
+          <a:xfrm>
+            <a:off x="731520" y="4727448"/>
+            <a:ext cx="2743200" cy="548640"/>
+          </a:xfrm>
+          <a:prstGeom prst="rect">
+            <a:avLst/>
+          </a:prstGeom>
+          <a:noFill/>
+        </p:spPr>
+        <p:txBody>
+          <a:bodyPr wrap="square" anchor="t" lIns="0" rIns="0" tIns="0" bIns="0">
+            <a:spAutoFit/>
+          </a:bodyPr>
+          <a:lstStyle/>
+          <a:p>
+            <a:pPr algn="l">
+              <a:spcBef>
+                <a:spcPts val="0"/>
+              </a:spcBef>
+              <a:spcAft>
+                <a:spcPts val="0"/>
+              </a:spcAft>
+            </a:pPr>
+            <a:r>
+              <a:rPr sz="1500" b="1" i="0">
+                <a:solidFill>
+                  <a:srgbClr val="17352A"/>
+                </a:solidFill>
+                <a:latin typeface="Georgia"/>
+              </a:rPr>
+              <a:t>CS / CA retainers</a:t>
+            </a:r>
+          </a:p>
+        </p:txBody>
+      </p:sp>
+      <p:sp>
+        <p:nvSpPr>
+          <p:cNvPr id="16" name="TextBox 15"/>
+          <p:cNvSpPr txBox="1"/>
+          <p:nvPr/>
+        </p:nvSpPr>
+        <p:spPr>
+          <a:xfrm>
+            <a:off x="3703320" y="4645152"/>
+            <a:ext cx="7802575" cy="685800"/>
+          </a:xfrm>
+          <a:prstGeom prst="rect">
+            <a:avLst/>
+          </a:prstGeom>
+          <a:noFill/>
+        </p:spPr>
+        <p:txBody>
+          <a:bodyPr wrap="square" anchor="ctr" lIns="0" rIns="0" tIns="0" bIns="0">
+            <a:spAutoFit/>
+          </a:bodyPr>
+          <a:lstStyle/>
+          <a:p>
+            <a:pPr algn="l">
+              <a:lnSpc>
+                <a:spcPct val="112000"/>
+              </a:lnSpc>
+              <a:spcBef>
+                <a:spcPts val="0"/>
+              </a:spcBef>
+              <a:spcAft>
+                <a:spcPts val="0"/>
+              </a:spcAft>
+            </a:pPr>
+            <a:r>
+              <a:rPr sz="1200" b="0" i="0">
+                <a:solidFill>
+                  <a:srgbClr val="5C6B62"/>
+                </a:solidFill>
+                <a:latin typeface="Segoe UI"/>
+              </a:rPr>
+              <a:t>The default today: reliable but manual, opaque and expensive, with company data trapped in someone's inbox.</a:t>
+            </a:r>
+          </a:p>
+        </p:txBody>
+      </p:sp>
+      <p:sp>
+        <p:nvSpPr>
+          <p:cNvPr id="17" name="Rectangle 16"/>
           <p:cNvSpPr/>
           <p:nvPr/>
         </p:nvSpPr>
         <p:spPr>
           <a:xfrm>
-            <a:off x="548640" y="4937760"/>
-            <a:ext cx="11094415" cy="841248"/>
+            <a:off x="731520" y="5330952"/>
+            <a:ext cx="10728655" cy="10972"/>
+          </a:xfrm>
+          <a:prstGeom prst="rect">
+            <a:avLst/>
+          </a:prstGeom>
+          <a:solidFill>
+            <a:srgbClr val="DDE3D8"/>
+          </a:solidFill>
+          <a:ln>
+            <a:noFill/>
+          </a:ln>
+          <a:effectLst/>
+        </p:spPr>
+        <p:style>
+          <a:lnRef idx="1">
+            <a:schemeClr val="accent1"/>
+          </a:lnRef>
+          <a:fillRef idx="3">
+            <a:schemeClr val="accent1"/>
+          </a:fillRef>
+          <a:effectRef idx="2">
+            <a:schemeClr val="accent1"/>
+          </a:effectRef>
+          <a:fontRef idx="minor">
+            <a:schemeClr val="lt1"/>
+          </a:fontRef>
+        </p:style>
+        <p:txBody>
+          <a:bodyPr rtlCol="0" anchor="ctr"/>
+          <a:lstStyle/>
+          <a:p>
+            <a:pPr algn="ctr"/>
+          </a:p>
+        </p:txBody>
+      </p:sp>
+      <p:sp>
+        <p:nvSpPr>
+          <p:cNvPr id="18" name="Rounded Rectangle 17"/>
+          <p:cNvSpPr/>
+          <p:nvPr/>
+        </p:nvSpPr>
+        <p:spPr>
+          <a:xfrm>
+            <a:off x="548640" y="5394960"/>
+            <a:ext cx="11094415" cy="749808"/>
           </a:xfrm>
           <a:prstGeom prst="roundRect">
             <a:avLst>
@@ -13270,13 +13401,13 @@
       </p:sp>
       <p:sp>
         <p:nvSpPr>
-          <p:cNvPr id="16" name="TextBox 15"/>
+          <p:cNvPr id="19" name="TextBox 18"/>
           <p:cNvSpPr txBox="1"/>
           <p:nvPr/>
         </p:nvSpPr>
         <p:spPr>
           <a:xfrm>
-            <a:off x="731520" y="5111496"/>
+            <a:off x="731520" y="5550408"/>
             <a:ext cx="2743200" cy="548640"/>
           </a:xfrm>
           <a:prstGeom prst="rect">
@@ -13299,7 +13430,7 @@
               </a:spcAft>
             </a:pPr>
             <a:r>
-              <a:rPr sz="1600" b="1" i="0">
+              <a:rPr sz="1500" b="1" i="0">
                 <a:solidFill>
                   <a:srgbClr val="17352A"/>
                 </a:solidFill>
@@ -13312,14 +13443,14 @@
       </p:sp>
       <p:sp>
         <p:nvSpPr>
-          <p:cNvPr id="17" name="TextBox 16"/>
+          <p:cNvPr id="20" name="TextBox 19"/>
           <p:cNvSpPr txBox="1"/>
           <p:nvPr/>
         </p:nvSpPr>
         <p:spPr>
           <a:xfrm>
-            <a:off x="3703320" y="5038344"/>
-            <a:ext cx="7802575" cy="731520"/>
+            <a:off x="3703320" y="5468112"/>
+            <a:ext cx="7802575" cy="685800"/>
           </a:xfrm>
           <a:prstGeom prst="rect">
             <a:avLst/>
@@ -13334,7 +13465,7 @@
           <a:p>
             <a:pPr algn="l">
               <a:lnSpc>
-                <a:spcPct val="115000"/>
+                <a:spcPct val="112000"/>
               </a:lnSpc>
               <a:spcBef>
                 <a:spcPts val="0"/>
@@ -13344,13 +13475,13 @@
               </a:spcAft>
             </a:pPr>
             <a:r>
-              <a:rPr sz="1300" b="0" i="0">
+              <a:rPr sz="1200" b="0" i="0">
                 <a:solidFill>
                   <a:srgbClr val="14231D"/>
                 </a:solidFill>
                 <a:latin typeface="Segoe UI"/>
               </a:rPr>
-              <a:t>One India-native platform across the entire lifecycle — company and fund — with compliance built in.</a:t>
+              <a:t>One India-native platform across the entire lifecycle — company and fund — with compliance and portfolio intelligence built in.</a:t>
             </a:r>
           </a:p>
         </p:txBody>
@@ -13610,7 +13741,7 @@
                 </a:solidFill>
                 <a:latin typeface="Segoe UI"/>
               </a:rPr>
-              <a:t>We have a working full-stack platform spanning incorporation, cap table, fundraising, governance, compliance and fund administration. Capital takes us from product to distribution — turning ~2 lakh startups and 1,849 funds into paying, expanding accounts.</a:t>
+              <a:t>We have a working full-stack platform spanning incorporation, cap table, fundraising, governance, compliance, fund administration and fund portfolio intelligence. Capital takes us from product to distribution — turning ~2 lakh startups and 1,849 funds into paying, expanding accounts.</a:t>
             </a:r>
           </a:p>
         </p:txBody>

</xml_diff>

<commit_message>
Investor pitch: product wording matches current platform (numbers unchanged)
- Founder pillar: "plan-based workspace — Starter → Growth → Scale".
- Product intro: notes the fund↔startup network effect (a company on Paper
  feeds its own numbers to the fund that backs it).
Mirrored in pitch.html and _build_pitch_ppt.py; deck rebuilt. Market data,
pricing tiers and projections left exactly as they were.

Co-Authored-By: Claude Opus 4.8 <noreply@anthropic.com>
</commit_message>
<xml_diff>
--- a/docs/Paper_Investor_Pitch.pptx
+++ b/docs/Paper_Investor_Pitch.pptx
@@ -5677,7 +5677,7 @@
                 </a:solidFill>
                 <a:latin typeface="Segoe UI"/>
               </a:rPr>
-              <a:t>Not a point tool bolted on — the workflow itself. Every artifact reads from one source of truth.</a:t>
+              <a:t>Not a point tool bolted on — the workflow itself. Every artifact reads from one source of truth; a company on Paper feeds its own numbers to the fund that backs it.</a:t>
             </a:r>
           </a:p>
         </p:txBody>
@@ -6564,7 +6564,7 @@
                 </a:solidFill>
                 <a:latin typeface="Segoe UI"/>
               </a:rPr>
-              <a:t>•  Stage-aware guidance — only what matters now</a:t>
+              <a:t>•  Plan-based workspace — Starter → Growth → Scale</a:t>
             </a:r>
           </a:p>
           <a:p>

</xml_diff>